<commit_message>
April 27 2026 — ECO 211 Ch2 lab, revised exams, new slides
New labs:
- eco211-lab-ch2: Chapter 2 (Choice In A World Of Scarcity)
  Copy of ECO 210 Ch2 with ECO 211 header, hub URL,
  localStorage key (econlab211_done_ch2), and Microeconomics
  OpenStax attribution. Needs testing.

Revised exam documents:
- ECO211-Final-Exam-Revised.docx: 32 questions, 20 pts total
  (0.625 pts each). Added Q31 (monopoly deadweight loss)
  and Q32 (monopolistic competition excess capacity).
  Footer and directions updated to reflect 32 questions.
- ECO211-Midterm-Exam-Revised.docx: 32 questions, 20 pts total
  (0.625 pts each). Rebalanced across Ch1-6, added sunk cost,
  marginal analysis, MU/P optimization, normal vs inferior
  goods questions. Price controls moved to Ch3.

Slides added to lecture-slides/:
- ECO211-Ch02-Choice-Scarcity.pptx (same as ECO 210 Ch2)
- ECO211-Ch06-Consumer-Choices.pptx
</commit_message>
<xml_diff>
--- a/Chapter-2-Lecture-Slides.pptx
+++ b/Chapter-2-Lecture-Slides.pptx
@@ -133,7 +133,7 @@
 <file path=ppt/revisionInfo.xml><?xml version="1.0" encoding="utf-8"?>
 <p1510:revInfo xmlns:a="http://schemas.openxmlformats.org/drawingml/2006/main" xmlns:r="http://schemas.openxmlformats.org/officeDocument/2006/relationships" xmlns:p1510="http://schemas.microsoft.com/office/powerpoint/2015/10/main">
   <p1510:revLst>
-    <p1510:client id="{C1A47391-CDF2-5F4C-88E6-BFA759A77521}" v="5" dt="2026-03-16T20:05:50.113"/>
+    <p1510:client id="{718D08A7-794C-4AD5-B36B-FDA7F7E3C5B5}" v="1" dt="2026-03-25T14:56:33.240"/>
   </p1510:revLst>
 </p1510:revInfo>
 </file>
@@ -141,14 +141,135 @@
 <file path=ppt/changesInfos/changesInfo1.xml><?xml version="1.0" encoding="utf-8"?>
 <pc:chgInfo xmlns:a="http://schemas.openxmlformats.org/drawingml/2006/main" xmlns:r="http://schemas.openxmlformats.org/officeDocument/2006/relationships" xmlns:ac="http://schemas.microsoft.com/office/drawing/2013/main/command" xmlns:pc="http://schemas.microsoft.com/office/powerpoint/2013/main/command">
   <pc:docChgLst>
+    <pc:chgData name="Scott T Lane" userId="c97bbaa9-35da-4a3b-a646-d12e455ac46e" providerId="ADAL" clId="{C8D54B54-DE85-4E6D-BD51-09B0B006B76A}"/>
+    <pc:docChg chg="modSld">
+      <pc:chgData name="Scott T Lane" userId="c97bbaa9-35da-4a3b-a646-d12e455ac46e" providerId="ADAL" clId="{C8D54B54-DE85-4E6D-BD51-09B0B006B76A}" dt="2026-03-19T12:55:57.504" v="0"/>
+      <pc:docMkLst>
+        <pc:docMk/>
+      </pc:docMkLst>
+      <pc:sldChg chg="delSp modTransition modAnim">
+        <pc:chgData name="Scott T Lane" userId="c97bbaa9-35da-4a3b-a646-d12e455ac46e" providerId="ADAL" clId="{C8D54B54-DE85-4E6D-BD51-09B0B006B76A}" dt="2026-03-19T12:55:57.504" v="0"/>
+        <pc:sldMkLst>
+          <pc:docMk/>
+          <pc:sldMk cId="2946475127" sldId="256"/>
+        </pc:sldMkLst>
+      </pc:sldChg>
+      <pc:sldChg chg="delSp modTransition modAnim">
+        <pc:chgData name="Scott T Lane" userId="c97bbaa9-35da-4a3b-a646-d12e455ac46e" providerId="ADAL" clId="{C8D54B54-DE85-4E6D-BD51-09B0B006B76A}" dt="2026-03-19T12:55:57.504" v="0"/>
+        <pc:sldMkLst>
+          <pc:docMk/>
+          <pc:sldMk cId="3227060347" sldId="261"/>
+        </pc:sldMkLst>
+      </pc:sldChg>
+      <pc:sldChg chg="delSp modTransition modAnim">
+        <pc:chgData name="Scott T Lane" userId="c97bbaa9-35da-4a3b-a646-d12e455ac46e" providerId="ADAL" clId="{C8D54B54-DE85-4E6D-BD51-09B0B006B76A}" dt="2026-03-19T12:55:57.504" v="0"/>
+        <pc:sldMkLst>
+          <pc:docMk/>
+          <pc:sldMk cId="3831852011" sldId="262"/>
+        </pc:sldMkLst>
+      </pc:sldChg>
+      <pc:sldChg chg="delSp modTransition modAnim">
+        <pc:chgData name="Scott T Lane" userId="c97bbaa9-35da-4a3b-a646-d12e455ac46e" providerId="ADAL" clId="{C8D54B54-DE85-4E6D-BD51-09B0B006B76A}" dt="2026-03-19T12:55:57.504" v="0"/>
+        <pc:sldMkLst>
+          <pc:docMk/>
+          <pc:sldMk cId="4118943851" sldId="263"/>
+        </pc:sldMkLst>
+      </pc:sldChg>
+      <pc:sldChg chg="delSp modTransition modAnim">
+        <pc:chgData name="Scott T Lane" userId="c97bbaa9-35da-4a3b-a646-d12e455ac46e" providerId="ADAL" clId="{C8D54B54-DE85-4E6D-BD51-09B0B006B76A}" dt="2026-03-19T12:55:57.504" v="0"/>
+        <pc:sldMkLst>
+          <pc:docMk/>
+          <pc:sldMk cId="67856451" sldId="265"/>
+        </pc:sldMkLst>
+      </pc:sldChg>
+      <pc:sldChg chg="delSp modTransition modAnim">
+        <pc:chgData name="Scott T Lane" userId="c97bbaa9-35da-4a3b-a646-d12e455ac46e" providerId="ADAL" clId="{C8D54B54-DE85-4E6D-BD51-09B0B006B76A}" dt="2026-03-19T12:55:57.504" v="0"/>
+        <pc:sldMkLst>
+          <pc:docMk/>
+          <pc:sldMk cId="442579116" sldId="268"/>
+        </pc:sldMkLst>
+      </pc:sldChg>
+      <pc:sldChg chg="delSp modTransition modAnim">
+        <pc:chgData name="Scott T Lane" userId="c97bbaa9-35da-4a3b-a646-d12e455ac46e" providerId="ADAL" clId="{C8D54B54-DE85-4E6D-BD51-09B0B006B76A}" dt="2026-03-19T12:55:57.504" v="0"/>
+        <pc:sldMkLst>
+          <pc:docMk/>
+          <pc:sldMk cId="2785958481" sldId="270"/>
+        </pc:sldMkLst>
+      </pc:sldChg>
+      <pc:sldChg chg="delSp modTransition modAnim">
+        <pc:chgData name="Scott T Lane" userId="c97bbaa9-35da-4a3b-a646-d12e455ac46e" providerId="ADAL" clId="{C8D54B54-DE85-4E6D-BD51-09B0B006B76A}" dt="2026-03-19T12:55:57.504" v="0"/>
+        <pc:sldMkLst>
+          <pc:docMk/>
+          <pc:sldMk cId="800195792" sldId="271"/>
+        </pc:sldMkLst>
+      </pc:sldChg>
+      <pc:sldChg chg="delSp modTransition modAnim">
+        <pc:chgData name="Scott T Lane" userId="c97bbaa9-35da-4a3b-a646-d12e455ac46e" providerId="ADAL" clId="{C8D54B54-DE85-4E6D-BD51-09B0B006B76A}" dt="2026-03-19T12:55:57.504" v="0"/>
+        <pc:sldMkLst>
+          <pc:docMk/>
+          <pc:sldMk cId="2929933221" sldId="272"/>
+        </pc:sldMkLst>
+      </pc:sldChg>
+      <pc:sldChg chg="delSp modTransition modAnim">
+        <pc:chgData name="Scott T Lane" userId="c97bbaa9-35da-4a3b-a646-d12e455ac46e" providerId="ADAL" clId="{C8D54B54-DE85-4E6D-BD51-09B0B006B76A}" dt="2026-03-19T12:55:57.504" v="0"/>
+        <pc:sldMkLst>
+          <pc:docMk/>
+          <pc:sldMk cId="2182262154" sldId="273"/>
+        </pc:sldMkLst>
+      </pc:sldChg>
+      <pc:sldChg chg="delSp modTransition modAnim">
+        <pc:chgData name="Scott T Lane" userId="c97bbaa9-35da-4a3b-a646-d12e455ac46e" providerId="ADAL" clId="{C8D54B54-DE85-4E6D-BD51-09B0B006B76A}" dt="2026-03-19T12:55:57.504" v="0"/>
+        <pc:sldMkLst>
+          <pc:docMk/>
+          <pc:sldMk cId="429486559" sldId="274"/>
+        </pc:sldMkLst>
+      </pc:sldChg>
+      <pc:sldChg chg="delSp modTransition modAnim">
+        <pc:chgData name="Scott T Lane" userId="c97bbaa9-35da-4a3b-a646-d12e455ac46e" providerId="ADAL" clId="{C8D54B54-DE85-4E6D-BD51-09B0B006B76A}" dt="2026-03-19T12:55:57.504" v="0"/>
+        <pc:sldMkLst>
+          <pc:docMk/>
+          <pc:sldMk cId="2404602200" sldId="278"/>
+        </pc:sldMkLst>
+      </pc:sldChg>
+      <pc:sldChg chg="delSp modTransition modAnim">
+        <pc:chgData name="Scott T Lane" userId="c97bbaa9-35da-4a3b-a646-d12e455ac46e" providerId="ADAL" clId="{C8D54B54-DE85-4E6D-BD51-09B0B006B76A}" dt="2026-03-19T12:55:57.504" v="0"/>
+        <pc:sldMkLst>
+          <pc:docMk/>
+          <pc:sldMk cId="1941270163" sldId="303"/>
+        </pc:sldMkLst>
+      </pc:sldChg>
+      <pc:sldChg chg="delSp modTransition modAnim">
+        <pc:chgData name="Scott T Lane" userId="c97bbaa9-35da-4a3b-a646-d12e455ac46e" providerId="ADAL" clId="{C8D54B54-DE85-4E6D-BD51-09B0B006B76A}" dt="2026-03-19T12:55:57.504" v="0"/>
+        <pc:sldMkLst>
+          <pc:docMk/>
+          <pc:sldMk cId="2328337475" sldId="309"/>
+        </pc:sldMkLst>
+      </pc:sldChg>
+      <pc:sldChg chg="delSp modTransition modAnim">
+        <pc:chgData name="Scott T Lane" userId="c97bbaa9-35da-4a3b-a646-d12e455ac46e" providerId="ADAL" clId="{C8D54B54-DE85-4E6D-BD51-09B0B006B76A}" dt="2026-03-19T12:55:57.504" v="0"/>
+        <pc:sldMkLst>
+          <pc:docMk/>
+          <pc:sldMk cId="1141452433" sldId="311"/>
+        </pc:sldMkLst>
+      </pc:sldChg>
+      <pc:sldChg chg="delSp modTransition modAnim">
+        <pc:chgData name="Scott T Lane" userId="c97bbaa9-35da-4a3b-a646-d12e455ac46e" providerId="ADAL" clId="{C8D54B54-DE85-4E6D-BD51-09B0B006B76A}" dt="2026-03-19T12:55:57.504" v="0"/>
+        <pc:sldMkLst>
+          <pc:docMk/>
+          <pc:sldMk cId="3242390494" sldId="312"/>
+        </pc:sldMkLst>
+      </pc:sldChg>
+    </pc:docChg>
+  </pc:docChgLst>
+  <pc:docChgLst>
     <pc:chgData name="Scott T Lane" userId="c97bbaa9-35da-4a3b-a646-d12e455ac46e" providerId="ADAL" clId="{7E70BB95-7D27-52BD-BFCA-66981E18D4F3}"/>
     <pc:docChg chg="undo custSel addSld delSld modSld sldOrd">
-      <pc:chgData name="Scott T Lane" userId="c97bbaa9-35da-4a3b-a646-d12e455ac46e" providerId="ADAL" clId="{7E70BB95-7D27-52BD-BFCA-66981E18D4F3}" dt="2026-03-16T20:06:46.044" v="431" actId="13244"/>
+      <pc:chgData name="Scott T Lane" userId="c97bbaa9-35da-4a3b-a646-d12e455ac46e" providerId="ADAL" clId="{7E70BB95-7D27-52BD-BFCA-66981E18D4F3}" dt="2026-03-10T18:49:45.368" v="421"/>
       <pc:docMkLst>
         <pc:docMk/>
       </pc:docMkLst>
       <pc:sldChg chg="addSp delSp modSp mod modTransition modAnim modNotesTx">
-        <pc:chgData name="Scott T Lane" userId="c97bbaa9-35da-4a3b-a646-d12e455ac46e" providerId="ADAL" clId="{7E70BB95-7D27-52BD-BFCA-66981E18D4F3}" dt="2026-03-16T20:01:35.817" v="422"/>
+        <pc:chgData name="Scott T Lane" userId="c97bbaa9-35da-4a3b-a646-d12e455ac46e" providerId="ADAL" clId="{7E70BB95-7D27-52BD-BFCA-66981E18D4F3}" dt="2026-03-10T18:49:45.368" v="421"/>
         <pc:sldMkLst>
           <pc:docMk/>
           <pc:sldMk cId="2946475127" sldId="256"/>
@@ -169,17 +290,9 @@
             <ac:spMk id="3" creationId="{046F5DC3-0C75-250B-266C-A3F19543BE11}"/>
           </ac:spMkLst>
         </pc:spChg>
-        <pc:picChg chg="add del mod">
-          <ac:chgData name="Scott T Lane" userId="c97bbaa9-35da-4a3b-a646-d12e455ac46e" providerId="ADAL" clId="{7E70BB95-7D27-52BD-BFCA-66981E18D4F3}" dt="2026-03-16T20:01:35.817" v="422"/>
-          <ac:picMkLst>
-            <pc:docMk/>
-            <pc:sldMk cId="2946475127" sldId="256"/>
-            <ac:picMk id="10" creationId="{FCE32802-E5C8-3686-D9DE-B9DC7FE6F6FA}"/>
-          </ac:picMkLst>
-        </pc:picChg>
       </pc:sldChg>
       <pc:sldChg chg="addSp delSp modSp mod modTransition modAnim modNotesTx">
-        <pc:chgData name="Scott T Lane" userId="c97bbaa9-35da-4a3b-a646-d12e455ac46e" providerId="ADAL" clId="{7E70BB95-7D27-52BD-BFCA-66981E18D4F3}" dt="2026-03-16T20:01:35.817" v="422"/>
+        <pc:chgData name="Scott T Lane" userId="c97bbaa9-35da-4a3b-a646-d12e455ac46e" providerId="ADAL" clId="{7E70BB95-7D27-52BD-BFCA-66981E18D4F3}" dt="2026-03-10T18:49:45.368" v="421"/>
         <pc:sldMkLst>
           <pc:docMk/>
           <pc:sldMk cId="3227060347" sldId="261"/>
@@ -208,17 +321,9 @@
             <ac:picMk id="2" creationId="{C788AFC6-E9CE-9571-7D5C-5627358CE61F}"/>
           </ac:picMkLst>
         </pc:picChg>
-        <pc:picChg chg="add del mod">
-          <ac:chgData name="Scott T Lane" userId="c97bbaa9-35da-4a3b-a646-d12e455ac46e" providerId="ADAL" clId="{7E70BB95-7D27-52BD-BFCA-66981E18D4F3}" dt="2026-03-16T20:01:35.817" v="422"/>
-          <ac:picMkLst>
-            <pc:docMk/>
-            <pc:sldMk cId="3227060347" sldId="261"/>
-            <ac:picMk id="12" creationId="{7A811A4F-A090-A00B-A5C3-F5CCE32F694B}"/>
-          </ac:picMkLst>
-        </pc:picChg>
       </pc:sldChg>
       <pc:sldChg chg="addSp delSp modSp mod modTransition modAnim modNotesTx">
-        <pc:chgData name="Scott T Lane" userId="c97bbaa9-35da-4a3b-a646-d12e455ac46e" providerId="ADAL" clId="{7E70BB95-7D27-52BD-BFCA-66981E18D4F3}" dt="2026-03-16T20:06:46.044" v="431" actId="13244"/>
+        <pc:chgData name="Scott T Lane" userId="c97bbaa9-35da-4a3b-a646-d12e455ac46e" providerId="ADAL" clId="{7E70BB95-7D27-52BD-BFCA-66981E18D4F3}" dt="2026-03-10T18:49:45.368" v="421"/>
         <pc:sldMkLst>
           <pc:docMk/>
           <pc:sldMk cId="3831852011" sldId="262"/>
@@ -231,33 +336,17 @@
             <ac:spMk id="6" creationId="{D67E9548-4905-7A26-4E13-2D3A869ECA4C}"/>
           </ac:spMkLst>
         </pc:spChg>
-        <pc:spChg chg="mod ord">
-          <ac:chgData name="Scott T Lane" userId="c97bbaa9-35da-4a3b-a646-d12e455ac46e" providerId="ADAL" clId="{7E70BB95-7D27-52BD-BFCA-66981E18D4F3}" dt="2026-03-16T20:06:46.044" v="431" actId="13244"/>
+        <pc:spChg chg="mod">
+          <ac:chgData name="Scott T Lane" userId="c97bbaa9-35da-4a3b-a646-d12e455ac46e" providerId="ADAL" clId="{7E70BB95-7D27-52BD-BFCA-66981E18D4F3}" dt="2026-03-09T19:19:09.788" v="128" actId="20577"/>
           <ac:spMkLst>
             <pc:docMk/>
             <pc:sldMk cId="3831852011" sldId="262"/>
             <ac:spMk id="7" creationId="{28866545-7087-FCCF-A3DD-4028291BC477}"/>
           </ac:spMkLst>
         </pc:spChg>
-        <pc:picChg chg="add mod">
-          <ac:chgData name="Scott T Lane" userId="c97bbaa9-35da-4a3b-a646-d12e455ac46e" providerId="ADAL" clId="{7E70BB95-7D27-52BD-BFCA-66981E18D4F3}" dt="2026-03-16T20:05:50.113" v="427" actId="14100"/>
-          <ac:picMkLst>
-            <pc:docMk/>
-            <pc:sldMk cId="3831852011" sldId="262"/>
-            <ac:picMk id="2" creationId="{AACB2D26-552D-3A9B-9A19-3D911D867B7D}"/>
-          </ac:picMkLst>
-        </pc:picChg>
-        <pc:picChg chg="add del mod">
-          <ac:chgData name="Scott T Lane" userId="c97bbaa9-35da-4a3b-a646-d12e455ac46e" providerId="ADAL" clId="{7E70BB95-7D27-52BD-BFCA-66981E18D4F3}" dt="2026-03-16T20:01:35.817" v="422"/>
-          <ac:picMkLst>
-            <pc:docMk/>
-            <pc:sldMk cId="3831852011" sldId="262"/>
-            <ac:picMk id="9" creationId="{6750C187-CBCC-F224-6584-A74A7CE3B299}"/>
-          </ac:picMkLst>
-        </pc:picChg>
       </pc:sldChg>
       <pc:sldChg chg="addSp delSp modSp mod modTransition modAnim modNotesTx">
-        <pc:chgData name="Scott T Lane" userId="c97bbaa9-35da-4a3b-a646-d12e455ac46e" providerId="ADAL" clId="{7E70BB95-7D27-52BD-BFCA-66981E18D4F3}" dt="2026-03-16T20:01:35.817" v="422"/>
+        <pc:chgData name="Scott T Lane" userId="c97bbaa9-35da-4a3b-a646-d12e455ac46e" providerId="ADAL" clId="{7E70BB95-7D27-52BD-BFCA-66981E18D4F3}" dt="2026-03-10T18:49:45.368" v="421"/>
         <pc:sldMkLst>
           <pc:docMk/>
           <pc:sldMk cId="4118943851" sldId="263"/>
@@ -286,17 +375,9 @@
             <ac:graphicFrameMk id="32" creationId="{493758C4-6AFA-10B3-22DD-1CAE5F9ED7CB}"/>
           </ac:graphicFrameMkLst>
         </pc:graphicFrameChg>
-        <pc:picChg chg="add del mod">
-          <ac:chgData name="Scott T Lane" userId="c97bbaa9-35da-4a3b-a646-d12e455ac46e" providerId="ADAL" clId="{7E70BB95-7D27-52BD-BFCA-66981E18D4F3}" dt="2026-03-16T20:01:35.817" v="422"/>
-          <ac:picMkLst>
-            <pc:docMk/>
-            <pc:sldMk cId="4118943851" sldId="263"/>
-            <ac:picMk id="4" creationId="{6E702D31-89E8-610D-1AF9-5646D129EBC9}"/>
-          </ac:picMkLst>
-        </pc:picChg>
       </pc:sldChg>
       <pc:sldChg chg="addSp delSp modSp mod modTransition modAnim modNotesTx">
-        <pc:chgData name="Scott T Lane" userId="c97bbaa9-35da-4a3b-a646-d12e455ac46e" providerId="ADAL" clId="{7E70BB95-7D27-52BD-BFCA-66981E18D4F3}" dt="2026-03-16T20:01:35.817" v="422"/>
+        <pc:chgData name="Scott T Lane" userId="c97bbaa9-35da-4a3b-a646-d12e455ac46e" providerId="ADAL" clId="{7E70BB95-7D27-52BD-BFCA-66981E18D4F3}" dt="2026-03-10T18:49:45.368" v="421"/>
         <pc:sldMkLst>
           <pc:docMk/>
           <pc:sldMk cId="67856451" sldId="265"/>
@@ -317,17 +398,9 @@
             <ac:spMk id="7" creationId="{28866545-7087-FCCF-A3DD-4028291BC477}"/>
           </ac:spMkLst>
         </pc:spChg>
-        <pc:picChg chg="add del mod">
-          <ac:chgData name="Scott T Lane" userId="c97bbaa9-35da-4a3b-a646-d12e455ac46e" providerId="ADAL" clId="{7E70BB95-7D27-52BD-BFCA-66981E18D4F3}" dt="2026-03-16T20:01:35.817" v="422"/>
-          <ac:picMkLst>
-            <pc:docMk/>
-            <pc:sldMk cId="67856451" sldId="265"/>
-            <ac:picMk id="4" creationId="{3E008561-E465-5B29-5F74-DF10D8DA0851}"/>
-          </ac:picMkLst>
-        </pc:picChg>
       </pc:sldChg>
       <pc:sldChg chg="addSp delSp modSp mod modTransition modAnim modNotesTx">
-        <pc:chgData name="Scott T Lane" userId="c97bbaa9-35da-4a3b-a646-d12e455ac46e" providerId="ADAL" clId="{7E70BB95-7D27-52BD-BFCA-66981E18D4F3}" dt="2026-03-16T20:01:35.817" v="422"/>
+        <pc:chgData name="Scott T Lane" userId="c97bbaa9-35da-4a3b-a646-d12e455ac46e" providerId="ADAL" clId="{7E70BB95-7D27-52BD-BFCA-66981E18D4F3}" dt="2026-03-10T18:49:45.368" v="421"/>
         <pc:sldMkLst>
           <pc:docMk/>
           <pc:sldMk cId="442579116" sldId="268"/>
@@ -372,17 +445,9 @@
             <ac:picMk id="2" creationId="{B97ECE04-54C1-1C21-93A1-6736967F04F8}"/>
           </ac:picMkLst>
         </pc:picChg>
-        <pc:picChg chg="add del mod">
-          <ac:chgData name="Scott T Lane" userId="c97bbaa9-35da-4a3b-a646-d12e455ac46e" providerId="ADAL" clId="{7E70BB95-7D27-52BD-BFCA-66981E18D4F3}" dt="2026-03-16T20:01:35.817" v="422"/>
-          <ac:picMkLst>
-            <pc:docMk/>
-            <pc:sldMk cId="442579116" sldId="268"/>
-            <ac:picMk id="9" creationId="{0567070D-734F-68BB-F0C3-037304F9C39D}"/>
-          </ac:picMkLst>
-        </pc:picChg>
       </pc:sldChg>
       <pc:sldChg chg="addSp delSp modSp mod modTransition modAnim modNotesTx">
-        <pc:chgData name="Scott T Lane" userId="c97bbaa9-35da-4a3b-a646-d12e455ac46e" providerId="ADAL" clId="{7E70BB95-7D27-52BD-BFCA-66981E18D4F3}" dt="2026-03-16T20:01:35.817" v="422"/>
+        <pc:chgData name="Scott T Lane" userId="c97bbaa9-35da-4a3b-a646-d12e455ac46e" providerId="ADAL" clId="{7E70BB95-7D27-52BD-BFCA-66981E18D4F3}" dt="2026-03-10T18:49:45.368" v="421"/>
         <pc:sldMkLst>
           <pc:docMk/>
           <pc:sldMk cId="2785958481" sldId="270"/>
@@ -403,17 +468,9 @@
             <ac:spMk id="7" creationId="{28866545-7087-FCCF-A3DD-4028291BC477}"/>
           </ac:spMkLst>
         </pc:spChg>
-        <pc:picChg chg="add del mod">
-          <ac:chgData name="Scott T Lane" userId="c97bbaa9-35da-4a3b-a646-d12e455ac46e" providerId="ADAL" clId="{7E70BB95-7D27-52BD-BFCA-66981E18D4F3}" dt="2026-03-16T20:01:35.817" v="422"/>
-          <ac:picMkLst>
-            <pc:docMk/>
-            <pc:sldMk cId="2785958481" sldId="270"/>
-            <ac:picMk id="4" creationId="{034FDE2C-B264-C3F7-18ED-5F3E985484A8}"/>
-          </ac:picMkLst>
-        </pc:picChg>
       </pc:sldChg>
       <pc:sldChg chg="addSp delSp modSp mod modTransition modAnim modNotesTx">
-        <pc:chgData name="Scott T Lane" userId="c97bbaa9-35da-4a3b-a646-d12e455ac46e" providerId="ADAL" clId="{7E70BB95-7D27-52BD-BFCA-66981E18D4F3}" dt="2026-03-16T20:01:35.817" v="422"/>
+        <pc:chgData name="Scott T Lane" userId="c97bbaa9-35da-4a3b-a646-d12e455ac46e" providerId="ADAL" clId="{7E70BB95-7D27-52BD-BFCA-66981E18D4F3}" dt="2026-03-10T18:49:45.368" v="421"/>
         <pc:sldMkLst>
           <pc:docMk/>
           <pc:sldMk cId="800195792" sldId="271"/>
@@ -434,17 +491,9 @@
             <ac:spMk id="7" creationId="{28866545-7087-FCCF-A3DD-4028291BC477}"/>
           </ac:spMkLst>
         </pc:spChg>
-        <pc:picChg chg="add del mod">
-          <ac:chgData name="Scott T Lane" userId="c97bbaa9-35da-4a3b-a646-d12e455ac46e" providerId="ADAL" clId="{7E70BB95-7D27-52BD-BFCA-66981E18D4F3}" dt="2026-03-16T20:01:35.817" v="422"/>
-          <ac:picMkLst>
-            <pc:docMk/>
-            <pc:sldMk cId="800195792" sldId="271"/>
-            <ac:picMk id="4" creationId="{5B4D4D5B-B09A-BECE-82AB-4B5247B36A6C}"/>
-          </ac:picMkLst>
-        </pc:picChg>
       </pc:sldChg>
       <pc:sldChg chg="addSp delSp modSp mod modTransition modAnim modNotesTx">
-        <pc:chgData name="Scott T Lane" userId="c97bbaa9-35da-4a3b-a646-d12e455ac46e" providerId="ADAL" clId="{7E70BB95-7D27-52BD-BFCA-66981E18D4F3}" dt="2026-03-16T20:01:35.817" v="422"/>
+        <pc:chgData name="Scott T Lane" userId="c97bbaa9-35da-4a3b-a646-d12e455ac46e" providerId="ADAL" clId="{7E70BB95-7D27-52BD-BFCA-66981E18D4F3}" dt="2026-03-10T18:49:45.368" v="421"/>
         <pc:sldMkLst>
           <pc:docMk/>
           <pc:sldMk cId="2929933221" sldId="272"/>
@@ -473,17 +522,9 @@
             <ac:graphicFrameMk id="2" creationId="{C47348D7-400A-CFA3-151D-90F595CCDE4C}"/>
           </ac:graphicFrameMkLst>
         </pc:graphicFrameChg>
-        <pc:picChg chg="add del mod">
-          <ac:chgData name="Scott T Lane" userId="c97bbaa9-35da-4a3b-a646-d12e455ac46e" providerId="ADAL" clId="{7E70BB95-7D27-52BD-BFCA-66981E18D4F3}" dt="2026-03-16T20:01:35.817" v="422"/>
-          <ac:picMkLst>
-            <pc:docMk/>
-            <pc:sldMk cId="2929933221" sldId="272"/>
-            <ac:picMk id="5" creationId="{88191FE6-6FF9-4F33-DB49-2A125375AA60}"/>
-          </ac:picMkLst>
-        </pc:picChg>
       </pc:sldChg>
       <pc:sldChg chg="addSp delSp modSp mod modTransition modAnim modNotesTx">
-        <pc:chgData name="Scott T Lane" userId="c97bbaa9-35da-4a3b-a646-d12e455ac46e" providerId="ADAL" clId="{7E70BB95-7D27-52BD-BFCA-66981E18D4F3}" dt="2026-03-16T20:01:35.817" v="422"/>
+        <pc:chgData name="Scott T Lane" userId="c97bbaa9-35da-4a3b-a646-d12e455ac46e" providerId="ADAL" clId="{7E70BB95-7D27-52BD-BFCA-66981E18D4F3}" dt="2026-03-10T18:49:45.368" v="421"/>
         <pc:sldMkLst>
           <pc:docMk/>
           <pc:sldMk cId="2182262154" sldId="273"/>
@@ -504,17 +545,9 @@
             <ac:spMk id="7" creationId="{28866545-7087-FCCF-A3DD-4028291BC477}"/>
           </ac:spMkLst>
         </pc:spChg>
-        <pc:picChg chg="add del mod">
-          <ac:chgData name="Scott T Lane" userId="c97bbaa9-35da-4a3b-a646-d12e455ac46e" providerId="ADAL" clId="{7E70BB95-7D27-52BD-BFCA-66981E18D4F3}" dt="2026-03-16T20:01:35.817" v="422"/>
-          <ac:picMkLst>
-            <pc:docMk/>
-            <pc:sldMk cId="2182262154" sldId="273"/>
-            <ac:picMk id="4" creationId="{3D06A06E-5854-7BEF-93B0-452887A6D571}"/>
-          </ac:picMkLst>
-        </pc:picChg>
       </pc:sldChg>
       <pc:sldChg chg="addSp delSp modSp mod modTransition modAnim modNotesTx">
-        <pc:chgData name="Scott T Lane" userId="c97bbaa9-35da-4a3b-a646-d12e455ac46e" providerId="ADAL" clId="{7E70BB95-7D27-52BD-BFCA-66981E18D4F3}" dt="2026-03-16T20:01:35.817" v="422"/>
+        <pc:chgData name="Scott T Lane" userId="c97bbaa9-35da-4a3b-a646-d12e455ac46e" providerId="ADAL" clId="{7E70BB95-7D27-52BD-BFCA-66981E18D4F3}" dt="2026-03-10T18:49:45.368" v="421"/>
         <pc:sldMkLst>
           <pc:docMk/>
           <pc:sldMk cId="429486559" sldId="274"/>
@@ -535,17 +568,9 @@
             <ac:spMk id="7" creationId="{28866545-7087-FCCF-A3DD-4028291BC477}"/>
           </ac:spMkLst>
         </pc:spChg>
-        <pc:picChg chg="add del mod">
-          <ac:chgData name="Scott T Lane" userId="c97bbaa9-35da-4a3b-a646-d12e455ac46e" providerId="ADAL" clId="{7E70BB95-7D27-52BD-BFCA-66981E18D4F3}" dt="2026-03-16T20:01:35.817" v="422"/>
-          <ac:picMkLst>
-            <pc:docMk/>
-            <pc:sldMk cId="429486559" sldId="274"/>
-            <ac:picMk id="4" creationId="{954F63CF-9CD9-93B5-D872-C45055596EB8}"/>
-          </ac:picMkLst>
-        </pc:picChg>
       </pc:sldChg>
       <pc:sldChg chg="addSp delSp modSp mod modTransition modAnim modNotesTx">
-        <pc:chgData name="Scott T Lane" userId="c97bbaa9-35da-4a3b-a646-d12e455ac46e" providerId="ADAL" clId="{7E70BB95-7D27-52BD-BFCA-66981E18D4F3}" dt="2026-03-16T20:01:35.817" v="422"/>
+        <pc:chgData name="Scott T Lane" userId="c97bbaa9-35da-4a3b-a646-d12e455ac46e" providerId="ADAL" clId="{7E70BB95-7D27-52BD-BFCA-66981E18D4F3}" dt="2026-03-10T18:49:45.368" v="421"/>
         <pc:sldMkLst>
           <pc:docMk/>
           <pc:sldMk cId="2404602200" sldId="278"/>
@@ -574,17 +599,9 @@
             <ac:picMk id="2" creationId="{9E8A5911-17FC-8750-3AE0-F778961CE16A}"/>
           </ac:picMkLst>
         </pc:picChg>
-        <pc:picChg chg="add del mod">
-          <ac:chgData name="Scott T Lane" userId="c97bbaa9-35da-4a3b-a646-d12e455ac46e" providerId="ADAL" clId="{7E70BB95-7D27-52BD-BFCA-66981E18D4F3}" dt="2026-03-16T20:01:35.817" v="422"/>
-          <ac:picMkLst>
-            <pc:docMk/>
-            <pc:sldMk cId="2404602200" sldId="278"/>
-            <ac:picMk id="5" creationId="{CAD870C2-2F16-9271-47BC-5AC171A12E0C}"/>
-          </ac:picMkLst>
-        </pc:picChg>
       </pc:sldChg>
       <pc:sldChg chg="addSp delSp modSp mod modTransition modAnim modNotesTx">
-        <pc:chgData name="Scott T Lane" userId="c97bbaa9-35da-4a3b-a646-d12e455ac46e" providerId="ADAL" clId="{7E70BB95-7D27-52BD-BFCA-66981E18D4F3}" dt="2026-03-16T20:01:35.817" v="422"/>
+        <pc:chgData name="Scott T Lane" userId="c97bbaa9-35da-4a3b-a646-d12e455ac46e" providerId="ADAL" clId="{7E70BB95-7D27-52BD-BFCA-66981E18D4F3}" dt="2026-03-10T18:49:45.368" v="421"/>
         <pc:sldMkLst>
           <pc:docMk/>
           <pc:sldMk cId="1941270163" sldId="303"/>
@@ -605,17 +622,9 @@
             <ac:spMk id="8" creationId="{E4AB994A-740F-62EB-342F-2455E13C0AF3}"/>
           </ac:spMkLst>
         </pc:spChg>
-        <pc:picChg chg="add del mod">
-          <ac:chgData name="Scott T Lane" userId="c97bbaa9-35da-4a3b-a646-d12e455ac46e" providerId="ADAL" clId="{7E70BB95-7D27-52BD-BFCA-66981E18D4F3}" dt="2026-03-16T20:01:35.817" v="422"/>
-          <ac:picMkLst>
-            <pc:docMk/>
-            <pc:sldMk cId="1941270163" sldId="303"/>
-            <ac:picMk id="4" creationId="{9B0B2E77-011E-56BB-0E21-987D335DEBE4}"/>
-          </ac:picMkLst>
-        </pc:picChg>
       </pc:sldChg>
       <pc:sldChg chg="addSp delSp modSp mod modTransition modAnim modNotesTx">
-        <pc:chgData name="Scott T Lane" userId="c97bbaa9-35da-4a3b-a646-d12e455ac46e" providerId="ADAL" clId="{7E70BB95-7D27-52BD-BFCA-66981E18D4F3}" dt="2026-03-16T20:01:35.817" v="422"/>
+        <pc:chgData name="Scott T Lane" userId="c97bbaa9-35da-4a3b-a646-d12e455ac46e" providerId="ADAL" clId="{7E70BB95-7D27-52BD-BFCA-66981E18D4F3}" dt="2026-03-10T18:49:45.368" v="421"/>
         <pc:sldMkLst>
           <pc:docMk/>
           <pc:sldMk cId="2328337475" sldId="309"/>
@@ -644,17 +653,9 @@
             <ac:picMk id="4" creationId="{433E9DEC-2C8A-5B3C-7281-643FF80EA582}"/>
           </ac:picMkLst>
         </pc:picChg>
-        <pc:picChg chg="add del mod">
-          <ac:chgData name="Scott T Lane" userId="c97bbaa9-35da-4a3b-a646-d12e455ac46e" providerId="ADAL" clId="{7E70BB95-7D27-52BD-BFCA-66981E18D4F3}" dt="2026-03-16T20:01:35.817" v="422"/>
-          <ac:picMkLst>
-            <pc:docMk/>
-            <pc:sldMk cId="2328337475" sldId="309"/>
-            <ac:picMk id="11" creationId="{1B96225D-477C-5DF9-38B8-A5338BE3A24F}"/>
-          </ac:picMkLst>
-        </pc:picChg>
       </pc:sldChg>
       <pc:sldChg chg="addSp delSp modSp mod ord modTransition modAnim modNotesTx">
-        <pc:chgData name="Scott T Lane" userId="c97bbaa9-35da-4a3b-a646-d12e455ac46e" providerId="ADAL" clId="{7E70BB95-7D27-52BD-BFCA-66981E18D4F3}" dt="2026-03-16T20:01:35.817" v="422"/>
+        <pc:chgData name="Scott T Lane" userId="c97bbaa9-35da-4a3b-a646-d12e455ac46e" providerId="ADAL" clId="{7E70BB95-7D27-52BD-BFCA-66981E18D4F3}" dt="2026-03-10T18:49:45.368" v="421"/>
         <pc:sldMkLst>
           <pc:docMk/>
           <pc:sldMk cId="1141452433" sldId="311"/>
@@ -667,17 +668,9 @@
             <ac:spMk id="3" creationId="{8AA65075-DD96-342C-2621-17FA83D4F571}"/>
           </ac:spMkLst>
         </pc:spChg>
-        <pc:picChg chg="add del mod">
-          <ac:chgData name="Scott T Lane" userId="c97bbaa9-35da-4a3b-a646-d12e455ac46e" providerId="ADAL" clId="{7E70BB95-7D27-52BD-BFCA-66981E18D4F3}" dt="2026-03-16T20:01:35.817" v="422"/>
-          <ac:picMkLst>
-            <pc:docMk/>
-            <pc:sldMk cId="1141452433" sldId="311"/>
-            <ac:picMk id="6" creationId="{843D7EA6-46E5-19CE-D08B-EC02CA3F76FF}"/>
-          </ac:picMkLst>
-        </pc:picChg>
       </pc:sldChg>
-      <pc:sldChg chg="addSp delSp modSp add mod modTransition modAnim modNotesTx">
-        <pc:chgData name="Scott T Lane" userId="c97bbaa9-35da-4a3b-a646-d12e455ac46e" providerId="ADAL" clId="{7E70BB95-7D27-52BD-BFCA-66981E18D4F3}" dt="2026-03-16T20:01:35.817" v="422"/>
+      <pc:sldChg chg="addSp modSp add mod modTransition modNotesTx">
+        <pc:chgData name="Scott T Lane" userId="c97bbaa9-35da-4a3b-a646-d12e455ac46e" providerId="ADAL" clId="{7E70BB95-7D27-52BD-BFCA-66981E18D4F3}" dt="2026-03-10T18:49:45.368" v="421"/>
         <pc:sldMkLst>
           <pc:docMk/>
           <pc:sldMk cId="3242390494" sldId="312"/>
@@ -698,21 +691,13 @@
             <ac:spMk id="8" creationId="{F4A9B425-0901-E1EA-3EB6-9790A435F52A}"/>
           </ac:spMkLst>
         </pc:spChg>
-        <pc:picChg chg="add del mod">
-          <ac:chgData name="Scott T Lane" userId="c97bbaa9-35da-4a3b-a646-d12e455ac46e" providerId="ADAL" clId="{7E70BB95-7D27-52BD-BFCA-66981E18D4F3}" dt="2026-03-16T20:01:35.817" v="422"/>
-          <ac:picMkLst>
-            <pc:docMk/>
-            <pc:sldMk cId="3242390494" sldId="312"/>
-            <ac:picMk id="4" creationId="{ED4FCD4A-E6B1-6F89-DA75-0C1F926FA64E}"/>
-          </ac:picMkLst>
-        </pc:picChg>
       </pc:sldChg>
     </pc:docChg>
   </pc:docChgLst>
   <pc:docChgLst>
     <pc:chgData name="Scott T Lane" userId="c97bbaa9-35da-4a3b-a646-d12e455ac46e" providerId="ADAL" clId="{2FF3E2E3-7818-4E76-9C63-7C10A568D9B9}"/>
     <pc:docChg chg="undo custSel addSld delSld modSld sldOrd modMainMaster">
-      <pc:chgData name="Scott T Lane" userId="c97bbaa9-35da-4a3b-a646-d12e455ac46e" providerId="ADAL" clId="{2FF3E2E3-7818-4E76-9C63-7C10A568D9B9}" dt="2026-02-27T17:35:10.853" v="394"/>
+      <pc:chgData name="Scott T Lane" userId="c97bbaa9-35da-4a3b-a646-d12e455ac46e" providerId="ADAL" clId="{2FF3E2E3-7818-4E76-9C63-7C10A568D9B9}" dt="2026-03-25T14:56:33.240" v="405" actId="478"/>
       <pc:docMkLst>
         <pc:docMk/>
       </pc:docMkLst>
@@ -762,8 +747,8 @@
           </ac:spMkLst>
         </pc:spChg>
       </pc:sldChg>
-      <pc:sldChg chg="addSp modSp mod">
-        <pc:chgData name="Scott T Lane" userId="c97bbaa9-35da-4a3b-a646-d12e455ac46e" providerId="ADAL" clId="{2FF3E2E3-7818-4E76-9C63-7C10A568D9B9}" dt="2026-02-27T17:25:28.861" v="392"/>
+      <pc:sldChg chg="addSp delSp modSp mod">
+        <pc:chgData name="Scott T Lane" userId="c97bbaa9-35da-4a3b-a646-d12e455ac46e" providerId="ADAL" clId="{2FF3E2E3-7818-4E76-9C63-7C10A568D9B9}" dt="2026-03-25T14:56:33.240" v="405" actId="478"/>
         <pc:sldMkLst>
           <pc:docMk/>
           <pc:sldMk cId="3831852011" sldId="262"/>
@@ -777,13 +762,21 @@
           </ac:spMkLst>
         </pc:spChg>
         <pc:spChg chg="mod">
-          <ac:chgData name="Scott T Lane" userId="c97bbaa9-35da-4a3b-a646-d12e455ac46e" providerId="ADAL" clId="{2FF3E2E3-7818-4E76-9C63-7C10A568D9B9}" dt="2026-02-27T15:05:34.418" v="52" actId="12"/>
+          <ac:chgData name="Scott T Lane" userId="c97bbaa9-35da-4a3b-a646-d12e455ac46e" providerId="ADAL" clId="{2FF3E2E3-7818-4E76-9C63-7C10A568D9B9}" dt="2026-03-17T12:12:47.817" v="404" actId="20577"/>
           <ac:spMkLst>
             <pc:docMk/>
             <pc:sldMk cId="3831852011" sldId="262"/>
             <ac:spMk id="7" creationId="{28866545-7087-FCCF-A3DD-4028291BC477}"/>
           </ac:spMkLst>
         </pc:spChg>
+        <pc:picChg chg="del">
+          <ac:chgData name="Scott T Lane" userId="c97bbaa9-35da-4a3b-a646-d12e455ac46e" providerId="ADAL" clId="{2FF3E2E3-7818-4E76-9C63-7C10A568D9B9}" dt="2026-03-25T14:56:33.240" v="405" actId="478"/>
+          <ac:picMkLst>
+            <pc:docMk/>
+            <pc:sldMk cId="3831852011" sldId="262"/>
+            <ac:picMk id="2" creationId="{AACB2D26-552D-3A9B-9A19-3D911D867B7D}"/>
+          </ac:picMkLst>
+        </pc:picChg>
       </pc:sldChg>
       <pc:sldChg chg="addSp modSp mod">
         <pc:chgData name="Scott T Lane" userId="c97bbaa9-35da-4a3b-a646-d12e455ac46e" providerId="ADAL" clId="{2FF3E2E3-7818-4E76-9C63-7C10A568D9B9}" dt="2026-02-27T17:25:28.861" v="392"/>
@@ -7762,7 +7755,7 @@
           <a:p>
             <a:fld id="{0AB8F3A2-8E25-4A3A-A5C5-30CE7D552B9E}" type="datetimeFigureOut">
               <a:rPr lang="en-US" smtClean="0"/>
-              <a:t>3/16/26</a:t>
+              <a:t>3/25/2026</a:t>
             </a:fld>
             <a:endParaRPr lang="en-US"/>
           </a:p>
@@ -9757,7 +9750,7 @@
           <a:p>
             <a:fld id="{1160EA64-D806-43AC-9DF2-F8C432F32B4C}" type="datetimeFigureOut">
               <a:rPr lang="en-US" dirty="0"/>
-              <a:t>3/16/26</a:t>
+              <a:t>3/25/2026</a:t>
             </a:fld>
             <a:endParaRPr lang="en-US" dirty="0"/>
           </a:p>
@@ -9929,7 +9922,7 @@
           <a:p>
             <a:fld id="{E9F9C37B-1D36-470B-8223-D6C91242EC14}" type="datetimeFigureOut">
               <a:rPr lang="en-US" dirty="0"/>
-              <a:t>3/16/26</a:t>
+              <a:t>3/25/2026</a:t>
             </a:fld>
             <a:endParaRPr lang="en-US" dirty="0"/>
           </a:p>
@@ -10110,7 +10103,7 @@
           <a:p>
             <a:fld id="{67C6F52A-A82B-47A2-A83A-8C4C91F2D59F}" type="datetimeFigureOut">
               <a:rPr lang="en-US" dirty="0"/>
-              <a:t>3/16/26</a:t>
+              <a:t>3/25/2026</a:t>
             </a:fld>
             <a:endParaRPr lang="en-US" dirty="0"/>
           </a:p>
@@ -10528,7 +10521,7 @@
           <a:p>
             <a:fld id="{F070A7B3-6521-4DCA-87E5-044747A908C1}" type="datetimeFigureOut">
               <a:rPr lang="en-US" dirty="0"/>
-              <a:t>3/16/26</a:t>
+              <a:t>3/25/2026</a:t>
             </a:fld>
             <a:endParaRPr lang="en-US" dirty="0"/>
           </a:p>
@@ -10798,7 +10791,7 @@
           <a:p>
             <a:fld id="{1160EA64-D806-43AC-9DF2-F8C432F32B4C}" type="datetimeFigureOut">
               <a:rPr lang="en-US" dirty="0"/>
-              <a:t>3/16/26</a:t>
+              <a:t>3/25/2026</a:t>
             </a:fld>
             <a:endParaRPr lang="en-US" dirty="0"/>
           </a:p>
@@ -11032,7 +11025,7 @@
           <a:p>
             <a:fld id="{AB134690-1557-4C89-A502-4959FE7FAD70}" type="datetimeFigureOut">
               <a:rPr lang="en-US" dirty="0"/>
-              <a:t>3/16/26</a:t>
+              <a:t>3/25/2026</a:t>
             </a:fld>
             <a:endParaRPr lang="en-US" dirty="0"/>
           </a:p>
@@ -11392,7 +11385,7 @@
           <a:p>
             <a:fld id="{4F7D4976-E339-4826-83B7-FBD03F55ECF8}" type="datetimeFigureOut">
               <a:rPr lang="en-US" dirty="0"/>
-              <a:t>3/16/26</a:t>
+              <a:t>3/25/2026</a:t>
             </a:fld>
             <a:endParaRPr lang="en-US" dirty="0"/>
           </a:p>
@@ -11534,7 +11527,7 @@
           <a:p>
             <a:fld id="{E1037C31-9E7A-4F99-8774-A0E530DE1A42}" type="datetimeFigureOut">
               <a:rPr lang="en-US" dirty="0"/>
-              <a:t>3/16/26</a:t>
+              <a:t>3/25/2026</a:t>
             </a:fld>
             <a:endParaRPr lang="en-US" dirty="0"/>
           </a:p>
@@ -11630,7 +11623,7 @@
           <a:p>
             <a:fld id="{C278504F-A551-4DE0-9316-4DCD1D8CC752}" type="datetimeFigureOut">
               <a:rPr lang="en-US" dirty="0"/>
-              <a:t>3/16/26</a:t>
+              <a:t>3/25/2026</a:t>
             </a:fld>
             <a:endParaRPr lang="en-US" dirty="0"/>
           </a:p>
@@ -11988,7 +11981,7 @@
           <a:p>
             <a:fld id="{D1BE4249-C0D0-4B06-8692-E8BB871AF643}" type="datetimeFigureOut">
               <a:rPr lang="en-US" dirty="0"/>
-              <a:t>3/16/26</a:t>
+              <a:t>3/25/2026</a:t>
             </a:fld>
             <a:endParaRPr lang="en-US" dirty="0"/>
           </a:p>
@@ -12346,7 +12339,7 @@
           <a:p>
             <a:fld id="{042B0DB6-F5C7-45FB-8CF3-31B45F9C2DAC}" type="datetimeFigureOut">
               <a:rPr lang="en-US" dirty="0"/>
-              <a:t>3/16/26</a:t>
+              <a:t>3/25/2026</a:t>
             </a:fld>
             <a:endParaRPr lang="en-US" dirty="0"/>
           </a:p>
@@ -12593,7 +12586,7 @@
           <a:p>
             <a:fld id="{1160EA64-D806-43AC-9DF2-F8C432F32B4C}" type="datetimeFigureOut">
               <a:rPr lang="en-US" dirty="0"/>
-              <a:t>3/16/26</a:t>
+              <a:t>3/25/2026</a:t>
             </a:fld>
             <a:endParaRPr lang="en-US" dirty="0"/>
           </a:p>
@@ -15083,9 +15076,6 @@
               <a:ext uri="{FF2B5EF4-FFF2-40B4-BE49-F238E27FC236}">
                 <a16:creationId xmlns:a16="http://schemas.microsoft.com/office/drawing/2014/main" id="{28866545-7087-FCCF-A3DD-4028291BC477}"/>
               </a:ext>
-              <a:ext uri="{C183D7F6-B498-43B3-948B-1728B52AA6E4}">
-                <adec:decorative xmlns:adec="http://schemas.microsoft.com/office/drawing/2017/decorative" val="0"/>
-              </a:ext>
             </a:extLst>
           </p:cNvPr>
           <p:cNvSpPr>
@@ -15098,7 +15088,7 @@
         <p:spPr>
           <a:xfrm>
             <a:off x="715652" y="1323610"/>
-            <a:ext cx="7252691" cy="5273133"/>
+            <a:ext cx="10515600" cy="5273133"/>
           </a:xfrm>
         </p:spPr>
         <p:txBody>
@@ -15175,7 +15165,7 @@
             </a:r>
             <a:r>
               <a:rPr lang="en-US" sz="2000" dirty="0"/>
-              <a:t> = $1,250/year (cost of a vacation)</a:t>
+              <a:t> = $2,920/year (cost of a vacation)</a:t>
             </a:r>
           </a:p>
           <a:p>
@@ -15203,57 +15193,6 @@
           </a:p>
         </p:txBody>
       </p:sp>
-      <p:pic>
-        <p:nvPicPr>
-          <p:cNvPr id="2" name="Picture 2" descr="Real-Life Examples of Opportunity Cost | St. Louis Fed">
-            <a:extLst>
-              <a:ext uri="{FF2B5EF4-FFF2-40B4-BE49-F238E27FC236}">
-                <a16:creationId xmlns:a16="http://schemas.microsoft.com/office/drawing/2014/main" id="{AACB2D26-552D-3A9B-9A19-3D911D867B7D}"/>
-              </a:ext>
-            </a:extLst>
-          </p:cNvPr>
-          <p:cNvPicPr>
-            <a:picLocks noChangeAspect="1" noChangeArrowheads="1"/>
-          </p:cNvPicPr>
-          <p:nvPr/>
-        </p:nvPicPr>
-        <p:blipFill>
-          <a:blip r:embed="rId3">
-            <a:extLst>
-              <a:ext uri="{28A0092B-C50C-407E-A947-70E740481C1C}">
-                <a14:useLocalDpi xmlns:a14="http://schemas.microsoft.com/office/drawing/2010/main" val="0"/>
-              </a:ext>
-            </a:extLst>
-          </a:blip>
-          <a:stretch>
-            <a:fillRect/>
-          </a:stretch>
-        </p:blipFill>
-        <p:spPr bwMode="auto">
-          <a:xfrm>
-            <a:off x="8098970" y="4167051"/>
-            <a:ext cx="3801265" cy="2316396"/>
-          </a:xfrm>
-          <a:prstGeom prst="rect">
-            <a:avLst/>
-          </a:prstGeom>
-          <a:noFill/>
-          <a:ln>
-            <a:solidFill>
-              <a:schemeClr val="tx1"/>
-            </a:solidFill>
-          </a:ln>
-          <a:extLst>
-            <a:ext uri="{909E8E84-426E-40DD-AFC4-6F175D3DCCD1}">
-              <a14:hiddenFill xmlns:a14="http://schemas.microsoft.com/office/drawing/2010/main">
-                <a:solidFill>
-                  <a:srgbClr val="FFFFFF"/>
-                </a:solidFill>
-              </a14:hiddenFill>
-            </a:ext>
-          </a:extLst>
-        </p:spPr>
-      </p:pic>
     </p:spTree>
     <p:extLst>
       <p:ext uri="{BB962C8B-B14F-4D97-AF65-F5344CB8AC3E}">

</xml_diff>